<commit_message>
Add per-SKU PPT: 2026-08-24_H5600001_S_580000.pptx
</commit_message>
<xml_diff>
--- a/ppt/2026-08-24_H5600001_S_580000.pptx
+++ b/ppt/2026-08-24_H5600001_S_580000.pptx
@@ -990,7 +990,7 @@
             </a:avLst>
           </a:prstGeom>
           <a:solidFill>
-            <a:srgbClr val="D97706"/>
+            <a:srgbClr val="6B7280"/>
           </a:solidFill>
           <a:ln/>
         </p:spPr>
@@ -1028,7 +1028,7 @@
                 <a:ea typeface="Microsoft JhengHei" pitchFamily="34" charset="-122"/>
                 <a:cs typeface="Microsoft JhengHei" pitchFamily="34" charset="-120"/>
               </a:rPr>
-              <a:t>🔥 中熱度</a:t>
+              <a:t>🔥 低熱度</a:t>
             </a:r>
             <a:endParaRPr lang="en-US" sz="1300" dirty="0"/>
           </a:p>
@@ -1692,7 +1692,7 @@
       </p:sp>
       <p:pic>
         <p:nvPicPr>
-          <p:cNvPr id="25" name="Image 0" descr="ppt_assets/yt_XMvn_rmPYLU.jpg">    </p:cNvPr>
+          <p:cNvPr id="25" name="Image 0" descr="/home/snkwok/newsfeed-scan/ppt_assets/yt_XMvn_rmPYLU.jpg">    </p:cNvPr>
           <p:cNvPicPr>
             <a:picLocks noChangeAspect="1"/>
           </p:cNvPicPr>
@@ -1767,7 +1767,7 @@
             <a:r>
               <a:rPr lang="en-US" sz="1200" b="1" dirty="0">
                 <a:solidFill>
-                  <a:srgbClr val="D97706"/>
+                  <a:srgbClr val="6B7280"/>
                 </a:solidFill>
                 <a:latin typeface="Microsoft JhengHei" pitchFamily="34" charset="0"/>
                 <a:ea typeface="Microsoft JhengHei" pitchFamily="34" charset="-122"/>

</xml_diff>